<commit_message>
Finalize PowerPoint deck and export PDF
Add homework challenge to the summary slide, export aula-mvc.pdf from
PowerPoint for the submission email, and switch doc references from
Google Slides to PowerPoint.

Co-Authored-By: Claude Opus 5.5 <noreply@anthropic.com>
</commit_message>
<xml_diff>
--- a/docs/aula-mvc.pptx
+++ b/docs/aula-mvc.pptx
@@ -1313,7 +1313,7 @@
           <a:p>
             <a:r>
               <a:rPr lang="en-US" dirty="0"/>
-              <a:t>Hoje vocês desenvolveram uma funcionalidade inteira em MVC. Com essa receita vocês conseguem criar editar, buscar, qualquer coisa — sempre camada por camada.</a:t>
+              <a:t>Hoje vocês desenvolveram uma funcionalidade inteira em MVC. Com essa receita vocês conseguem criar editar, buscar, qualquer coisa — sempre camada por camada. Fica o desafio: desenvolver o Editar nota seguindo a mesma receita.</a:t>
             </a:r>
             <a:endParaRPr lang="en-US" dirty="0"/>
           </a:p>
@@ -6831,6 +6831,81 @@
           </a:p>
         </p:txBody>
       </p:sp>
+      <p:sp>
+        <p:nvSpPr>
+          <p:cNvPr id="11" name="Shape 9"/>
+          <p:cNvSpPr/>
+          <p:nvPr/>
+        </p:nvSpPr>
+        <p:spPr>
+          <a:xfrm>
+            <a:off x="457200" y="3657600"/>
+            <a:ext cx="8229600" cy="914400"/>
+          </a:xfrm>
+          <a:prstGeom prst="roundRect">
+            <a:avLst>
+              <a:gd name="adj" fmla="val 8000"/>
+            </a:avLst>
+          </a:prstGeom>
+          <a:solidFill>
+            <a:srgbClr val="F1F3F6"/>
+          </a:solidFill>
+          <a:ln/>
+        </p:spPr>
+      </p:sp>
+      <p:sp>
+        <p:nvSpPr>
+          <p:cNvPr id="12" name="Text 10"/>
+          <p:cNvSpPr txBox="1"/>
+          <p:nvPr/>
+        </p:nvSpPr>
+        <p:spPr>
+          <a:xfrm>
+            <a:off x="731520" y="3657600"/>
+            <a:ext cx="7680960" cy="914400"/>
+          </a:xfrm>
+          <a:prstGeom prst="rect">
+            <a:avLst/>
+          </a:prstGeom>
+          <a:noFill/>
+          <a:ln/>
+        </p:spPr>
+        <p:txBody>
+          <a:bodyPr wrap="square" lIns="0" tIns="0" rIns="0" bIns="0" rtlCol="0" anchor="ctr"/>
+          <a:lstStyle/>
+          <a:p>
+            <a:pPr indent="0" marL="0">
+              <a:buNone/>
+            </a:pPr>
+            <a:r>
+              <a:rPr lang="en-US" sz="1600" b="1" dirty="0">
+                <a:solidFill>
+                  <a:srgbClr val="C8553D"/>
+                </a:solidFill>
+                <a:latin typeface="Arial" pitchFamily="34" charset="0"/>
+                <a:ea typeface="Arial" pitchFamily="34" charset="-122"/>
+                <a:cs typeface="Arial" pitchFamily="34" charset="-120"/>
+              </a:rPr>
+              <a:t>Desafio para casa: </a:t>
+            </a:r>
+            <a:pPr indent="0" marL="0">
+              <a:buNone/>
+            </a:pPr>
+            <a:r>
+              <a:rPr lang="en-US" sz="1600" dirty="0">
+                <a:solidFill>
+                  <a:srgbClr val="1F2430"/>
+                </a:solidFill>
+                <a:latin typeface="Arial" pitchFamily="34" charset="0"/>
+                <a:ea typeface="Arial" pitchFamily="34" charset="-122"/>
+                <a:cs typeface="Arial" pitchFamily="34" charset="-120"/>
+              </a:rPr>
+              <a:t>desenvolva a função "Editar nota" seguindo a mesma receita — Model → Controller → Rota → View → Testar.</a:t>
+            </a:r>
+            <a:endParaRPr lang="en-US" sz="1600" dirty="0"/>
+          </a:p>
+        </p:txBody>
+      </p:sp>
     </p:spTree>
   </p:cSld>
   <p:clrMapOvr>

</xml_diff>

<commit_message>
Complete delete feature and harden error handling in app-mvc
Add the delete button to the view, validate the note id in the model and
handle errors in every controller action so an invalid request no longer
crashes the server. Show save errors on screen and fix textarea font.
Sync slides, slide text, lesson plan and PDFs with the updated code.

Co-Authored-By: Claude Opus 5.5 <noreply@anthropic.com>
</commit_message>
<xml_diff>
--- a/docs/aula-mvc.pptx
+++ b/docs/aula-mvc.pptx
@@ -784,7 +784,7 @@
           <a:p>
             <a:r>
               <a:rPr lang="en-US" dirty="0"/>
-              <a:t>Pergunta: onde fica o comando que apaga do banco? No Model! Reparem que ele não sabe nada de botão ou tela. O $1 protege contra SQL Injection.</a:t>
+              <a:t>Em qual camada fica o comando que apaga do banco? No Model! Primeiro ele valida a regra — o id precisa ser um número — e depois apaga. Reparem que ele não sabe nada de botão ou tela. O $1 protege contra SQL Injection.</a:t>
             </a:r>
             <a:endParaRPr lang="en-US" dirty="0"/>
           </a:p>
@@ -872,7 +872,7 @@
           <a:p>
             <a:r>
               <a:rPr lang="en-US" dirty="0"/>
-              <a:t>O Controller pega o id que veio na URL, pede ao Model para remover e responde 204 — 'deu certo, sem conteúdo'. Ele orquestra, não acessa o banco diretamente.</a:t>
+              <a:t>O Controller pega o id que veio na URL, pede ao Model para remover e responde 204 — 'deu certo, sem conteúdo'. Se o Model recusar, por exemplo com um id inválido, o catch devolve 400 com a mensagem de erro, e o servidor continua de pé. Ele orquestra, não acessa o banco diretamente.</a:t>
             </a:r>
             <a:endParaRPr lang="en-US" dirty="0"/>
           </a:p>
@@ -4418,6 +4418,63 @@
                 <a:ea typeface="Courier New" pitchFamily="34" charset="-122"/>
                 <a:cs typeface="Courier New" pitchFamily="34" charset="-120"/>
               </a:rPr>
+              <a:t>  if (!Number.isInteger(Number(id))) {</a:t>
+            </a:r>
+            <a:endParaRPr lang="en-US" sz="1500" dirty="0"/>
+          </a:p>
+          <a:p>
+            <a:pPr indent="0" marL="0">
+              <a:buNone/>
+            </a:pPr>
+            <a:r>
+              <a:rPr lang="en-US" sz="1500" dirty="0">
+                <a:solidFill>
+                  <a:srgbClr val="E8E8E8"/>
+                </a:solidFill>
+                <a:latin typeface="Courier New" pitchFamily="34" charset="0"/>
+                <a:ea typeface="Courier New" pitchFamily="34" charset="-122"/>
+                <a:cs typeface="Courier New" pitchFamily="34" charset="-120"/>
+              </a:rPr>
+              <a:t>    throw new Error("Id inválido");</a:t>
+            </a:r>
+            <a:endParaRPr lang="en-US" sz="1500" dirty="0"/>
+          </a:p>
+          <a:p>
+            <a:pPr indent="0" marL="0">
+              <a:buNone/>
+            </a:pPr>
+            <a:r>
+              <a:rPr lang="en-US" sz="1500" dirty="0">
+                <a:solidFill>
+                  <a:srgbClr val="E8E8E8"/>
+                </a:solidFill>
+                <a:latin typeface="Courier New" pitchFamily="34" charset="0"/>
+                <a:ea typeface="Courier New" pitchFamily="34" charset="-122"/>
+                <a:cs typeface="Courier New" pitchFamily="34" charset="-120"/>
+              </a:rPr>
+              <a:t>  }</a:t>
+            </a:r>
+            <a:endParaRPr lang="en-US" sz="1500" dirty="0"/>
+          </a:p>
+          <a:p>
+            <a:pPr indent="0" marL="0">
+              <a:buNone/>
+            </a:pPr>
+            <a:endParaRPr lang="en-US" sz="1500" dirty="0"/>
+          </a:p>
+          <a:p>
+            <a:pPr indent="0" marL="0">
+              <a:buNone/>
+            </a:pPr>
+            <a:r>
+              <a:rPr lang="en-US" sz="1500" dirty="0">
+                <a:solidFill>
+                  <a:srgbClr val="E8E8E8"/>
+                </a:solidFill>
+                <a:latin typeface="Courier New" pitchFamily="34" charset="0"/>
+                <a:ea typeface="Courier New" pitchFamily="34" charset="-122"/>
+                <a:cs typeface="Courier New" pitchFamily="34" charset="-120"/>
+              </a:rPr>
               <a:t>  await pool.query(</a:t>
             </a:r>
             <a:endParaRPr lang="en-US" sz="1500" dirty="0"/>
@@ -4547,7 +4604,7 @@
                 <a:ea typeface="Arial" pitchFamily="34" charset="-122"/>
                 <a:cs typeface="Arial" pitchFamily="34" charset="-120"/>
               </a:rPr>
-              <a:t>Onde fica o comando que apaga do banco?</a:t>
+              <a:t>Regra: o id precisa ser um número.</a:t>
             </a:r>
             <a:endParaRPr lang="en-US" sz="1500" dirty="0"/>
           </a:p>
@@ -4570,7 +4627,7 @@
                 <a:ea typeface="Arial" pitchFamily="34" charset="-122"/>
                 <a:cs typeface="Arial" pitchFamily="34" charset="-120"/>
               </a:rPr>
-              <a:t>No Model.</a:t>
+              <a:t>Depois, apaga do banco.</a:t>
             </a:r>
             <a:endParaRPr lang="en-US" sz="1500" dirty="0"/>
           </a:p>
@@ -4593,7 +4650,7 @@
                 <a:ea typeface="Arial" pitchFamily="34" charset="-122"/>
                 <a:cs typeface="Arial" pitchFamily="34" charset="-120"/>
               </a:rPr>
-              <a:t>Ele não sabe nada de botão ou tela.</a:t>
+              <a:t>Não sabe nada de botão ou tela.</a:t>
             </a:r>
             <a:endParaRPr lang="en-US" sz="1500" dirty="0"/>
           </a:p>
@@ -4803,7 +4860,7 @@
                 <a:ea typeface="Courier New" pitchFamily="34" charset="-122"/>
                 <a:cs typeface="Courier New" pitchFamily="34" charset="-120"/>
               </a:rPr>
-              <a:t>  await Nota.remover(requisicao.params.id);</a:t>
+              <a:t>  try {</a:t>
             </a:r>
             <a:endParaRPr lang="en-US" sz="1500" dirty="0"/>
           </a:p>
@@ -4820,7 +4877,92 @@
                 <a:ea typeface="Courier New" pitchFamily="34" charset="-122"/>
                 <a:cs typeface="Courier New" pitchFamily="34" charset="-120"/>
               </a:rPr>
-              <a:t>  resposta.status(204).send();</a:t>
+              <a:t>    await Nota.remover(requisicao.params.id);</a:t>
+            </a:r>
+            <a:endParaRPr lang="en-US" sz="1500" dirty="0"/>
+          </a:p>
+          <a:p>
+            <a:pPr indent="0" marL="0">
+              <a:buNone/>
+            </a:pPr>
+            <a:r>
+              <a:rPr lang="en-US" sz="1500" dirty="0">
+                <a:solidFill>
+                  <a:srgbClr val="E8E8E8"/>
+                </a:solidFill>
+                <a:latin typeface="Courier New" pitchFamily="34" charset="0"/>
+                <a:ea typeface="Courier New" pitchFamily="34" charset="-122"/>
+                <a:cs typeface="Courier New" pitchFamily="34" charset="-120"/>
+              </a:rPr>
+              <a:t>    resposta.status(204).send();</a:t>
+            </a:r>
+            <a:endParaRPr lang="en-US" sz="1500" dirty="0"/>
+          </a:p>
+          <a:p>
+            <a:pPr indent="0" marL="0">
+              <a:buNone/>
+            </a:pPr>
+            <a:r>
+              <a:rPr lang="en-US" sz="1500" dirty="0">
+                <a:solidFill>
+                  <a:srgbClr val="E8E8E8"/>
+                </a:solidFill>
+                <a:latin typeface="Courier New" pitchFamily="34" charset="0"/>
+                <a:ea typeface="Courier New" pitchFamily="34" charset="-122"/>
+                <a:cs typeface="Courier New" pitchFamily="34" charset="-120"/>
+              </a:rPr>
+              <a:t>  } catch (erro) {</a:t>
+            </a:r>
+            <a:endParaRPr lang="en-US" sz="1500" dirty="0"/>
+          </a:p>
+          <a:p>
+            <a:pPr indent="0" marL="0">
+              <a:buNone/>
+            </a:pPr>
+            <a:r>
+              <a:rPr lang="en-US" sz="1500" dirty="0">
+                <a:solidFill>
+                  <a:srgbClr val="E8E8E8"/>
+                </a:solidFill>
+                <a:latin typeface="Courier New" pitchFamily="34" charset="0"/>
+                <a:ea typeface="Courier New" pitchFamily="34" charset="-122"/>
+                <a:cs typeface="Courier New" pitchFamily="34" charset="-120"/>
+              </a:rPr>
+              <a:t>    resposta.status(400)</a:t>
+            </a:r>
+            <a:endParaRPr lang="en-US" sz="1500" dirty="0"/>
+          </a:p>
+          <a:p>
+            <a:pPr indent="0" marL="0">
+              <a:buNone/>
+            </a:pPr>
+            <a:r>
+              <a:rPr lang="en-US" sz="1500" dirty="0">
+                <a:solidFill>
+                  <a:srgbClr val="E8E8E8"/>
+                </a:solidFill>
+                <a:latin typeface="Courier New" pitchFamily="34" charset="0"/>
+                <a:ea typeface="Courier New" pitchFamily="34" charset="-122"/>
+                <a:cs typeface="Courier New" pitchFamily="34" charset="-120"/>
+              </a:rPr>
+              <a:t>      .json({ erro: erro.message });</a:t>
+            </a:r>
+            <a:endParaRPr lang="en-US" sz="1500" dirty="0"/>
+          </a:p>
+          <a:p>
+            <a:pPr indent="0" marL="0">
+              <a:buNone/>
+            </a:pPr>
+            <a:r>
+              <a:rPr lang="en-US" sz="1500" dirty="0">
+                <a:solidFill>
+                  <a:srgbClr val="E8E8E8"/>
+                </a:solidFill>
+                <a:latin typeface="Courier New" pitchFamily="34" charset="0"/>
+                <a:ea typeface="Courier New" pitchFamily="34" charset="-122"/>
+                <a:cs typeface="Courier New" pitchFamily="34" charset="-120"/>
+              </a:rPr>
+              <a:t>  }</a:t>
             </a:r>
             <a:endParaRPr lang="en-US" sz="1500" dirty="0"/>
           </a:p>
@@ -4921,14 +5063,8 @@
                 <a:ea typeface="Arial" pitchFamily="34" charset="-122"/>
                 <a:cs typeface="Arial" pitchFamily="34" charset="-120"/>
               </a:rPr>
-              <a:t>204 = deu certo, sem conteúdo.</a:t>
-            </a:r>
-            <a:endParaRPr lang="en-US" sz="1500" dirty="0"/>
-          </a:p>
-          <a:p>
-            <a:pPr indent="0" marL="0">
-              <a:buNone/>
-            </a:pPr>
+              <a:t>204 = deu certo.</a:t>
+            </a:r>
             <a:endParaRPr lang="en-US" sz="1500" dirty="0"/>
           </a:p>
           <a:p>
@@ -4944,7 +5080,30 @@
                 <a:ea typeface="Arial" pitchFamily="34" charset="-122"/>
                 <a:cs typeface="Arial" pitchFamily="34" charset="-120"/>
               </a:rPr>
-              <a:t>Orquestra, não acessa o banco.</a:t>
+              <a:t>400 = erro tratado, o servidor não cai.</a:t>
+            </a:r>
+            <a:endParaRPr lang="en-US" sz="1500" dirty="0"/>
+          </a:p>
+          <a:p>
+            <a:pPr indent="0" marL="0">
+              <a:buNone/>
+            </a:pPr>
+            <a:endParaRPr lang="en-US" sz="1500" dirty="0"/>
+          </a:p>
+          <a:p>
+            <a:pPr indent="0" marL="0">
+              <a:buNone/>
+            </a:pPr>
+            <a:r>
+              <a:rPr lang="en-US" sz="1500" dirty="0">
+                <a:solidFill>
+                  <a:srgbClr val="1F2430"/>
+                </a:solidFill>
+                <a:latin typeface="Arial" pitchFamily="34" charset="0"/>
+                <a:ea typeface="Arial" pitchFamily="34" charset="-122"/>
+                <a:cs typeface="Arial" pitchFamily="34" charset="-120"/>
+              </a:rPr>
+              <a:t>Não acessa o banco.</a:t>
             </a:r>
             <a:endParaRPr lang="en-US" sz="1500" dirty="0"/>
           </a:p>

</xml_diff>

<commit_message>
Rebuild app-sem-mvc as a full-featured monolith
Give the non-MVC contrast app the same features as app-mvc (create,
list, favorite, delete, same layout) backed by the same PostgreSQL
table, with SQL, rules and HTML mixed in a single server.js. Update the
monolith snippet on slide 2, the slide text and the README.

Co-Authored-By: Claude Opus 5.5 <noreply@anthropic.com>
</commit_message>
<xml_diff>
--- a/docs/aula-mvc.pptx
+++ b/docs/aula-mvc.pptx
@@ -1490,7 +1490,7 @@
             <a:r>
               <a:rPr lang="en-US" dirty="0"/>
               <a:t>Mostrar ao vivo: app-sem-mvc/server.js.
-Olhem esse arquivo, um monólito: o HTML, a validação e os dados estão todos juntos na mesma rota. Funciona? Funciona. Mas se eu precisar mudar só o visual, vou mexer no mesmo lugar onde está a regra. Isso é risco. Reparem nas cores: vermelho recebe o pedido, verde é regra e dado, amarelo é tela. As três responsabilidades já estão aí, só que embaralhadas. Pergunta pra vocês: como organizariam esse código?</a:t>
+Olhem essa rota do monólito: na mesma função está a consulta ao banco, a regra de negócio — favoritas primeiro — e o HTML da tela. Funciona? Funciona. Mas se eu precisar mudar só o visual, vou mexer no mesmo lugar onde está a regra. Isso é risco. Reparem nas cores: vermelho recebe o pedido, verde é dado e regra, amarelo é tela. As três responsabilidades já estão aí, só que embaralhadas. Pergunta pra vocês: como organizariam esse código?</a:t>
             </a:r>
             <a:endParaRPr lang="en-US" dirty="0"/>
           </a:p>
@@ -7580,7 +7580,7 @@
               <a:buNone/>
             </a:pPr>
             <a:r>
-              <a:rPr lang="en-US" sz="1300" dirty="0">
+              <a:rPr lang="en-US" sz="1200" dirty="0">
                 <a:solidFill>
                   <a:srgbClr val="8B93A5"/>
                 </a:solidFill>
@@ -7590,48 +7590,48 @@
               </a:rPr>
               <a:t>// app-sem-mvc/server.js</a:t>
             </a:r>
-            <a:endParaRPr lang="en-US" sz="1300" dirty="0"/>
-          </a:p>
-          <a:p>
-            <a:pPr indent="0" marL="0">
-              <a:buNone/>
-            </a:pPr>
-            <a:r>
-              <a:rPr lang="en-US" sz="1300" dirty="0">
-                <a:solidFill>
-                  <a:srgbClr val="E8E8E8"/>
+            <a:endParaRPr lang="en-US" sz="1200" dirty="0"/>
+          </a:p>
+          <a:p>
+            <a:pPr indent="0" marL="0">
+              <a:buNone/>
+            </a:pPr>
+            <a:r>
+              <a:rPr lang="en-US" sz="1200" dirty="0">
+                <a:solidFill>
+                  <a:srgbClr val="F29A85"/>
                 </a:solidFill>
                 <a:latin typeface="Courier New" pitchFamily="34" charset="0"/>
                 <a:ea typeface="Courier New" pitchFamily="34" charset="-122"/>
                 <a:cs typeface="Courier New" pitchFamily="34" charset="-120"/>
               </a:rPr>
-              <a:t>app.post("/notas", (req, res) =&gt; {</a:t>
-            </a:r>
-            <a:endParaRPr lang="en-US" sz="1300" dirty="0"/>
-          </a:p>
-          <a:p>
-            <a:pPr indent="0" marL="0">
-              <a:buNone/>
-            </a:pPr>
-            <a:r>
-              <a:rPr lang="en-US" sz="1300" dirty="0">
-                <a:solidFill>
-                  <a:srgbClr val="F29A85"/>
+              <a:t>app.get("/", async (req, res) =&gt; {</a:t>
+            </a:r>
+            <a:endParaRPr lang="en-US" sz="1200" dirty="0"/>
+          </a:p>
+          <a:p>
+            <a:pPr indent="0" marL="0">
+              <a:buNone/>
+            </a:pPr>
+            <a:r>
+              <a:rPr lang="en-US" sz="1200" dirty="0">
+                <a:solidFill>
+                  <a:srgbClr val="6FD39A"/>
                 </a:solidFill>
                 <a:latin typeface="Courier New" pitchFamily="34" charset="0"/>
                 <a:ea typeface="Courier New" pitchFamily="34" charset="-122"/>
                 <a:cs typeface="Courier New" pitchFamily="34" charset="-120"/>
               </a:rPr>
-              <a:t>  const { titulo } = req.body;</a:t>
-            </a:r>
-            <a:endParaRPr lang="en-US" sz="1300" dirty="0"/>
-          </a:p>
-          <a:p>
-            <a:pPr indent="0" marL="0">
-              <a:buNone/>
-            </a:pPr>
-            <a:r>
-              <a:rPr lang="en-US" sz="1300" dirty="0">
+              <a:t>  const r = await pool.query(</a:t>
+            </a:r>
+            <a:endParaRPr lang="en-US" sz="1200" dirty="0"/>
+          </a:p>
+          <a:p>
+            <a:pPr indent="0" marL="0">
+              <a:buNone/>
+            </a:pPr>
+            <a:r>
+              <a:rPr lang="en-US" sz="1200" dirty="0">
                 <a:solidFill>
                   <a:srgbClr val="6FD39A"/>
                 </a:solidFill>
@@ -7639,16 +7639,16 @@
                 <a:ea typeface="Courier New" pitchFamily="34" charset="-122"/>
                 <a:cs typeface="Courier New" pitchFamily="34" charset="-120"/>
               </a:rPr>
-              <a:t>  if (!titulo)</a:t>
-            </a:r>
-            <a:endParaRPr lang="en-US" sz="1300" dirty="0"/>
-          </a:p>
-          <a:p>
-            <a:pPr indent="0" marL="0">
-              <a:buNone/>
-            </a:pPr>
-            <a:r>
-              <a:rPr lang="en-US" sz="1300" dirty="0">
+              <a:t>    "SELECT * FROM notas ORDER BY " +</a:t>
+            </a:r>
+            <a:endParaRPr lang="en-US" sz="1200" dirty="0"/>
+          </a:p>
+          <a:p>
+            <a:pPr indent="0" marL="0">
+              <a:buNone/>
+            </a:pPr>
+            <a:r>
+              <a:rPr lang="en-US" sz="1200" dirty="0">
                 <a:solidFill>
                   <a:srgbClr val="6FD39A"/>
                 </a:solidFill>
@@ -7656,33 +7656,33 @@
                 <a:ea typeface="Courier New" pitchFamily="34" charset="-122"/>
                 <a:cs typeface="Courier New" pitchFamily="34" charset="-120"/>
               </a:rPr>
-              <a:t>    return res.send("Erro");</a:t>
-            </a:r>
-            <a:endParaRPr lang="en-US" sz="1300" dirty="0"/>
-          </a:p>
-          <a:p>
-            <a:pPr indent="0" marL="0">
-              <a:buNone/>
-            </a:pPr>
-            <a:r>
-              <a:rPr lang="en-US" sz="1300" dirty="0">
-                <a:solidFill>
-                  <a:srgbClr val="6FD39A"/>
+              <a:t>    "favorita DESC, criado_em DESC");</a:t>
+            </a:r>
+            <a:endParaRPr lang="en-US" sz="1200" dirty="0"/>
+          </a:p>
+          <a:p>
+            <a:pPr indent="0" marL="0">
+              <a:buNone/>
+            </a:pPr>
+            <a:r>
+              <a:rPr lang="en-US" sz="1200" dirty="0">
+                <a:solidFill>
+                  <a:srgbClr val="F2B84B"/>
                 </a:solidFill>
                 <a:latin typeface="Courier New" pitchFamily="34" charset="0"/>
                 <a:ea typeface="Courier New" pitchFamily="34" charset="-122"/>
                 <a:cs typeface="Courier New" pitchFamily="34" charset="-120"/>
               </a:rPr>
-              <a:t>  notas.push({ titulo });</a:t>
-            </a:r>
-            <a:endParaRPr lang="en-US" sz="1300" dirty="0"/>
-          </a:p>
-          <a:p>
-            <a:pPr indent="0" marL="0">
-              <a:buNone/>
-            </a:pPr>
-            <a:r>
-              <a:rPr lang="en-US" sz="1300" dirty="0">
+              <a:t>  const html = r.rows.map((n) =&gt;</a:t>
+            </a:r>
+            <a:endParaRPr lang="en-US" sz="1200" dirty="0"/>
+          </a:p>
+          <a:p>
+            <a:pPr indent="0" marL="0">
+              <a:buNone/>
+            </a:pPr>
+            <a:r>
+              <a:rPr lang="en-US" sz="1200" dirty="0">
                 <a:solidFill>
                   <a:srgbClr val="F2B84B"/>
                 </a:solidFill>
@@ -7690,16 +7690,16 @@
                 <a:ea typeface="Courier New" pitchFamily="34" charset="-122"/>
                 <a:cs typeface="Courier New" pitchFamily="34" charset="-120"/>
               </a:rPr>
-              <a:t>  res.send(`&lt;html&gt;</a:t>
-            </a:r>
-            <a:endParaRPr lang="en-US" sz="1300" dirty="0"/>
-          </a:p>
-          <a:p>
-            <a:pPr indent="0" marL="0">
-              <a:buNone/>
-            </a:pPr>
-            <a:r>
-              <a:rPr lang="en-US" sz="1300" dirty="0">
+              <a:t>    `&lt;li&gt;${n.titulo}&lt;/li&gt;`).join("");</a:t>
+            </a:r>
+            <a:endParaRPr lang="en-US" sz="1200" dirty="0"/>
+          </a:p>
+          <a:p>
+            <a:pPr indent="0" marL="0">
+              <a:buNone/>
+            </a:pPr>
+            <a:r>
+              <a:rPr lang="en-US" sz="1200" dirty="0">
                 <a:solidFill>
                   <a:srgbClr val="F2B84B"/>
                 </a:solidFill>
@@ -7707,43 +7707,26 @@
                 <a:ea typeface="Courier New" pitchFamily="34" charset="-122"/>
                 <a:cs typeface="Courier New" pitchFamily="34" charset="-120"/>
               </a:rPr>
-              <a:t>    &lt;ul&gt;${linhas}&lt;/ul&gt;</a:t>
-            </a:r>
-            <a:endParaRPr lang="en-US" sz="1300" dirty="0"/>
-          </a:p>
-          <a:p>
-            <a:pPr indent="0" marL="0">
-              <a:buNone/>
-            </a:pPr>
-            <a:r>
-              <a:rPr lang="en-US" sz="1300" dirty="0">
-                <a:solidFill>
-                  <a:srgbClr val="F2B84B"/>
+              <a:t>  res.send(`&lt;ul&gt;${html}&lt;/ul&gt;`);</a:t>
+            </a:r>
+            <a:endParaRPr lang="en-US" sz="1200" dirty="0"/>
+          </a:p>
+          <a:p>
+            <a:pPr indent="0" marL="0">
+              <a:buNone/>
+            </a:pPr>
+            <a:r>
+              <a:rPr lang="en-US" sz="1200" dirty="0">
+                <a:solidFill>
+                  <a:srgbClr val="E8E8E8"/>
                 </a:solidFill>
                 <a:latin typeface="Courier New" pitchFamily="34" charset="0"/>
                 <a:ea typeface="Courier New" pitchFamily="34" charset="-122"/>
                 <a:cs typeface="Courier New" pitchFamily="34" charset="-120"/>
               </a:rPr>
-              <a:t>  &lt;/html&gt;`);</a:t>
-            </a:r>
-            <a:endParaRPr lang="en-US" sz="1300" dirty="0"/>
-          </a:p>
-          <a:p>
-            <a:pPr indent="0" marL="0">
-              <a:buNone/>
-            </a:pPr>
-            <a:r>
-              <a:rPr lang="en-US" sz="1300" dirty="0">
-                <a:solidFill>
-                  <a:srgbClr val="E8E8E8"/>
-                </a:solidFill>
-                <a:latin typeface="Courier New" pitchFamily="34" charset="0"/>
-                <a:ea typeface="Courier New" pitchFamily="34" charset="-122"/>
-                <a:cs typeface="Courier New" pitchFamily="34" charset="-120"/>
-              </a:rPr>
               <a:t>});</a:t>
             </a:r>
-            <a:endParaRPr lang="en-US" sz="1300" dirty="0"/>
+            <a:endParaRPr lang="en-US" sz="1200" dirty="0"/>
           </a:p>
         </p:txBody>
       </p:sp>

</xml_diff>

<commit_message>
Show a larger real monolith excerpt on slide 2
Replace the short snippet with 22 real lines from app-sem-mvc/server.js
using the file's own names, color-coded by layer, plus a "1 arquivo ·
153 linhas" callout to convey the monolith's size.

Co-Authored-By: Claude Opus 5.5 <noreply@anthropic.com>
</commit_message>
<xml_diff>
--- a/docs/aula-mvc.pptx
+++ b/docs/aula-mvc.pptx
@@ -1489,8 +1489,8 @@
           <a:p>
             <a:r>
               <a:rPr lang="en-US" dirty="0"/>
-              <a:t>Mostrar ao vivo: app-sem-mvc/server.js.
-Olhem essa rota do monólito: na mesma função está a consulta ao banco, a regra de negócio — favoritas primeiro — e o HTML da tela. Funciona? Funciona. Mas se eu precisar mudar só o visual, vou mexer no mesmo lugar onde está a regra. Isso é risco. Reparem nas cores: vermelho recebe o pedido, verde é dado e regra, amarelo é tela. As três responsabilidades já estão aí, só que embaralhadas. Pergunta pra vocês: como organizariam esse código?</a:t>
+              <a:t>Mostrar ao vivo: app-sem-mvc/server.js, rolando o arquivo inteiro.
+Olhem esse arquivo: é o mesmo sistema de notas, com as mesmas funções, mas tudo num arquivo só — 153 linhas. Na mesma rota está a conexão com o banco, o SQL, a regra de negócio — favoritas primeiro —, a validação e o HTML da tela, até o CSS. Funciona? Funciona. Mas se eu precisar mudar só o visual, vou mexer no mesmo lugar onde está a regra. Isso é risco. Reparem nas cores: vermelho recebe o pedido, verde é dado e regra, amarelo é tela. As três responsabilidades já estão aí, só que embaralhadas. Pergunta pra vocês: como organizariam esse código?</a:t>
             </a:r>
             <a:endParaRPr lang="en-US" dirty="0"/>
           </a:p>
@@ -7382,7 +7382,7 @@
         <p:spPr>
           <a:xfrm>
             <a:off x="457200" y="1097280"/>
-            <a:ext cx="4023360" cy="2194560"/>
+            <a:ext cx="2926080" cy="1737360"/>
           </a:xfrm>
           <a:prstGeom prst="rect">
             <a:avLst/>
@@ -7402,7 +7402,7 @@
               <a:buChar char="•"/>
             </a:pPr>
             <a:r>
-              <a:rPr lang="en-US" sz="1700" dirty="0">
+              <a:rPr lang="en-US" sz="1400" dirty="0">
                 <a:solidFill>
                   <a:srgbClr val="1F2430"/>
                 </a:solidFill>
@@ -7410,9 +7410,9 @@
                 <a:ea typeface="Arial" pitchFamily="34" charset="-122"/>
                 <a:cs typeface="Arial" pitchFamily="34" charset="-120"/>
               </a:rPr>
-              <a:t>Tela, regras e banco de dados no mesmo arquivo</a:t>
-            </a:r>
-            <a:endParaRPr lang="en-US" sz="1700" dirty="0"/>
+              <a:t>Tela, regras e banco no mesmo arquivo</a:t>
+            </a:r>
+            <a:endParaRPr lang="en-US" sz="1400" dirty="0"/>
           </a:p>
           <a:p>
             <a:pPr marL="342900" indent="-342900">
@@ -7423,7 +7423,7 @@
               <a:buChar char="•"/>
             </a:pPr>
             <a:r>
-              <a:rPr lang="en-US" sz="1700" dirty="0">
+              <a:rPr lang="en-US" sz="1400" dirty="0">
                 <a:solidFill>
                   <a:srgbClr val="1F2430"/>
                 </a:solidFill>
@@ -7431,9 +7431,9 @@
                 <a:ea typeface="Arial" pitchFamily="34" charset="-122"/>
                 <a:cs typeface="Arial" pitchFamily="34" charset="-120"/>
               </a:rPr>
-              <a:t>Mudar o visual pode quebrar a regra de negócio</a:t>
-            </a:r>
-            <a:endParaRPr lang="en-US" sz="1700" dirty="0"/>
+              <a:t>Mudar o visual pode quebrar a regra</a:t>
+            </a:r>
+            <a:endParaRPr lang="en-US" sz="1400" dirty="0"/>
           </a:p>
           <a:p>
             <a:pPr marL="342900" indent="-342900">
@@ -7444,7 +7444,7 @@
               <a:buChar char="•"/>
             </a:pPr>
             <a:r>
-              <a:rPr lang="en-US" sz="1700" dirty="0">
+              <a:rPr lang="en-US" sz="1400" dirty="0">
                 <a:solidFill>
                   <a:srgbClr val="1F2430"/>
                 </a:solidFill>
@@ -7454,7 +7454,7 @@
               </a:rPr>
               <a:t>Difícil de testar, manter e dividir na equipe</a:t>
             </a:r>
-            <a:endParaRPr lang="en-US" sz="1700" dirty="0"/>
+            <a:endParaRPr lang="en-US" sz="1400" dirty="0"/>
           </a:p>
         </p:txBody>
       </p:sp>
@@ -7466,12 +7466,90 @@
         </p:nvSpPr>
         <p:spPr>
           <a:xfrm>
-            <a:off x="457200" y="3383280"/>
-            <a:ext cx="4023360" cy="1188720"/>
+            <a:off x="457200" y="2743200"/>
+            <a:ext cx="2926080" cy="914400"/>
           </a:xfrm>
           <a:prstGeom prst="roundRect">
             <a:avLst>
-              <a:gd name="adj" fmla="val 6154"/>
+              <a:gd name="adj" fmla="val 8000"/>
+            </a:avLst>
+          </a:prstGeom>
+          <a:solidFill>
+            <a:srgbClr val="1F2430"/>
+          </a:solidFill>
+          <a:ln/>
+        </p:spPr>
+      </p:sp>
+      <p:sp>
+        <p:nvSpPr>
+          <p:cNvPr id="5" name="Text 3"/>
+          <p:cNvSpPr txBox="1"/>
+          <p:nvPr/>
+        </p:nvSpPr>
+        <p:spPr>
+          <a:xfrm>
+            <a:off x="457200" y="2743200"/>
+            <a:ext cx="2926080" cy="914400"/>
+          </a:xfrm>
+          <a:prstGeom prst="rect">
+            <a:avLst/>
+          </a:prstGeom>
+          <a:noFill/>
+          <a:ln/>
+        </p:spPr>
+        <p:txBody>
+          <a:bodyPr wrap="square" lIns="0" tIns="0" rIns="0" bIns="0" rtlCol="0" anchor="ctr"/>
+          <a:lstStyle/>
+          <a:p>
+            <a:pPr algn="ctr" indent="0" marL="0">
+              <a:buNone/>
+            </a:pPr>
+            <a:r>
+              <a:rPr lang="en-US" sz="1700" b="1" dirty="0">
+                <a:solidFill>
+                  <a:srgbClr val="FFFFFF"/>
+                </a:solidFill>
+                <a:latin typeface="Arial" pitchFamily="34" charset="0"/>
+                <a:ea typeface="Arial" pitchFamily="34" charset="-122"/>
+                <a:cs typeface="Arial" pitchFamily="34" charset="-120"/>
+              </a:rPr>
+              <a:t>1 arquivo · 153 linhas</a:t>
+            </a:r>
+            <a:endParaRPr lang="en-US" sz="1700" dirty="0"/>
+          </a:p>
+          <a:p>
+            <a:pPr algn="ctr" indent="0" marL="0">
+              <a:buNone/>
+            </a:pPr>
+            <a:r>
+              <a:rPr lang="en-US" sz="1100" dirty="0">
+                <a:solidFill>
+                  <a:srgbClr val="C9CED8"/>
+                </a:solidFill>
+                <a:latin typeface="Arial" pitchFamily="34" charset="0"/>
+                <a:ea typeface="Arial" pitchFamily="34" charset="-122"/>
+                <a:cs typeface="Arial" pitchFamily="34" charset="-120"/>
+              </a:rPr>
+              <a:t>4 rotas · 5 consultas SQL · HTML e CSS</a:t>
+            </a:r>
+            <a:endParaRPr lang="en-US" sz="1700" dirty="0"/>
+          </a:p>
+        </p:txBody>
+      </p:sp>
+      <p:sp>
+        <p:nvSpPr>
+          <p:cNvPr id="6" name="Shape 4"/>
+          <p:cNvSpPr/>
+          <p:nvPr/>
+        </p:nvSpPr>
+        <p:spPr>
+          <a:xfrm>
+            <a:off x="457200" y="3840480"/>
+            <a:ext cx="2926080" cy="1097280"/>
+          </a:xfrm>
+          <a:prstGeom prst="roundRect">
+            <a:avLst>
+              <a:gd name="adj" fmla="val 6667"/>
             </a:avLst>
           </a:prstGeom>
           <a:solidFill>
@@ -7482,14 +7560,14 @@
       </p:sp>
       <p:sp>
         <p:nvSpPr>
-          <p:cNvPr id="5" name="Text 3"/>
-          <p:cNvSpPr txBox="1"/>
-          <p:nvPr/>
-        </p:nvSpPr>
-        <p:spPr>
-          <a:xfrm>
-            <a:off x="640080" y="3474720"/>
-            <a:ext cx="3657600" cy="1005840"/>
+          <p:cNvPr id="7" name="Text 5"/>
+          <p:cNvSpPr txBox="1"/>
+          <p:nvPr/>
+        </p:nvSpPr>
+        <p:spPr>
+          <a:xfrm>
+            <a:off x="594360" y="3840480"/>
+            <a:ext cx="2651760" cy="1097280"/>
           </a:xfrm>
           <a:prstGeom prst="rect">
             <a:avLst/>
@@ -7505,7 +7583,7 @@
               <a:buNone/>
             </a:pPr>
             <a:r>
-              <a:rPr lang="en-US" sz="1500" b="1" dirty="0">
+              <a:rPr lang="en-US" sz="1300" b="1" dirty="0">
                 <a:solidFill>
                   <a:srgbClr val="1F2430"/>
                 </a:solidFill>
@@ -7519,7 +7597,7 @@
               <a:buNone/>
             </a:pPr>
             <a:r>
-              <a:rPr lang="en-US" sz="1500" dirty="0">
+              <a:rPr lang="en-US" sz="1300" dirty="0">
                 <a:solidFill>
                   <a:srgbClr val="1F2430"/>
                 </a:solidFill>
@@ -7529,24 +7607,91 @@
               </a:rPr>
               <a:t>organizar o app de anotações em MVC e criar a função "Excluir nota".</a:t>
             </a:r>
-            <a:endParaRPr lang="en-US" sz="1500" dirty="0"/>
-          </a:p>
-        </p:txBody>
-      </p:sp>
-      <p:sp>
-        <p:nvSpPr>
-          <p:cNvPr id="6" name="Shape 4"/>
+            <a:endParaRPr lang="en-US" sz="1300" dirty="0"/>
+          </a:p>
+        </p:txBody>
+      </p:sp>
+      <p:sp>
+        <p:nvSpPr>
+          <p:cNvPr id="8" name="Text 6"/>
+          <p:cNvSpPr txBox="1"/>
+          <p:nvPr/>
+        </p:nvSpPr>
+        <p:spPr>
+          <a:xfrm>
+            <a:off x="3611880" y="868680"/>
+            <a:ext cx="5074920" cy="274320"/>
+          </a:xfrm>
+          <a:prstGeom prst="rect">
+            <a:avLst/>
+          </a:prstGeom>
+          <a:noFill/>
+          <a:ln/>
+        </p:spPr>
+        <p:txBody>
+          <a:bodyPr wrap="square" lIns="0" tIns="0" rIns="0" bIns="0" rtlCol="0" anchor="ctr"/>
+          <a:lstStyle/>
+          <a:p>
+            <a:pPr algn="r" indent="0" marL="0">
+              <a:buNone/>
+            </a:pPr>
+            <a:r>
+              <a:rPr lang="en-US" sz="1200" b="1" dirty="0">
+                <a:solidFill>
+                  <a:srgbClr val="C8553D"/>
+                </a:solidFill>
+                <a:latin typeface="Arial" pitchFamily="34" charset="0"/>
+                <a:ea typeface="Arial" pitchFamily="34" charset="-122"/>
+                <a:cs typeface="Arial" pitchFamily="34" charset="-120"/>
+              </a:rPr>
+              <a:t>■ Controller  </a:t>
+            </a:r>
+            <a:pPr algn="r" indent="0" marL="0">
+              <a:buNone/>
+            </a:pPr>
+            <a:r>
+              <a:rPr lang="en-US" sz="1200" b="1" dirty="0">
+                <a:solidFill>
+                  <a:srgbClr val="2E8B57"/>
+                </a:solidFill>
+                <a:latin typeface="Arial" pitchFamily="34" charset="0"/>
+                <a:ea typeface="Arial" pitchFamily="34" charset="-122"/>
+                <a:cs typeface="Arial" pitchFamily="34" charset="-120"/>
+              </a:rPr>
+              <a:t>■ Model  </a:t>
+            </a:r>
+            <a:pPr algn="r" indent="0" marL="0">
+              <a:buNone/>
+            </a:pPr>
+            <a:r>
+              <a:rPr lang="en-US" sz="1200" b="1" dirty="0">
+                <a:solidFill>
+                  <a:srgbClr val="D98E04"/>
+                </a:solidFill>
+                <a:latin typeface="Arial" pitchFamily="34" charset="0"/>
+                <a:ea typeface="Arial" pitchFamily="34" charset="-122"/>
+                <a:cs typeface="Arial" pitchFamily="34" charset="-120"/>
+              </a:rPr>
+              <a:t>■ View</a:t>
+            </a:r>
+            <a:endParaRPr lang="en-US" sz="1200" dirty="0"/>
+          </a:p>
+        </p:txBody>
+      </p:sp>
+      <p:sp>
+        <p:nvSpPr>
+          <p:cNvPr id="9" name="Shape 7"/>
           <p:cNvSpPr/>
           <p:nvPr/>
         </p:nvSpPr>
         <p:spPr>
           <a:xfrm>
-            <a:off x="4754880" y="1097280"/>
-            <a:ext cx="3931920" cy="3474720"/>
+            <a:off x="3611880" y="1188720"/>
+            <a:ext cx="5074920" cy="3749040"/>
           </a:xfrm>
           <a:prstGeom prst="roundRect">
             <a:avLst>
-              <a:gd name="adj" fmla="val 2105"/>
+              <a:gd name="adj" fmla="val 1951"/>
             </a:avLst>
           </a:prstGeom>
           <a:solidFill>
@@ -7557,14 +7702,14 @@
       </p:sp>
       <p:sp>
         <p:nvSpPr>
-          <p:cNvPr id="7" name="Text 5"/>
-          <p:cNvSpPr txBox="1"/>
-          <p:nvPr/>
-        </p:nvSpPr>
-        <p:spPr>
-          <a:xfrm>
-            <a:off x="4937760" y="1234440"/>
-            <a:ext cx="3566160" cy="2651760"/>
+          <p:cNvPr id="10" name="Text 8"/>
+          <p:cNvSpPr txBox="1"/>
+          <p:nvPr/>
+        </p:nvSpPr>
+        <p:spPr>
+          <a:xfrm>
+            <a:off x="3794760" y="1298448"/>
+            <a:ext cx="4754880" cy="3566160"/>
           </a:xfrm>
           <a:prstGeom prst="rect">
             <a:avLst/>
@@ -7580,7 +7725,7 @@
               <a:buNone/>
             </a:pPr>
             <a:r>
-              <a:rPr lang="en-US" sz="1200" dirty="0">
+              <a:rPr lang="en-US" sz="1000" dirty="0">
                 <a:solidFill>
                   <a:srgbClr val="8B93A5"/>
                 </a:solidFill>
@@ -7588,50 +7733,50 @@
                 <a:ea typeface="Courier New" pitchFamily="34" charset="-122"/>
                 <a:cs typeface="Courier New" pitchFamily="34" charset="-120"/>
               </a:rPr>
-              <a:t>// app-sem-mvc/server.js</a:t>
-            </a:r>
-            <a:endParaRPr lang="en-US" sz="1200" dirty="0"/>
-          </a:p>
-          <a:p>
-            <a:pPr indent="0" marL="0">
-              <a:buNone/>
-            </a:pPr>
-            <a:r>
-              <a:rPr lang="en-US" sz="1200" dirty="0">
-                <a:solidFill>
-                  <a:srgbClr val="F29A85"/>
+              <a:t>// app-sem-mvc/server.js (trechos)</a:t>
+            </a:r>
+            <a:endParaRPr lang="en-US" sz="1000" dirty="0"/>
+          </a:p>
+          <a:p>
+            <a:pPr indent="0" marL="0">
+              <a:buNone/>
+            </a:pPr>
+            <a:r>
+              <a:rPr lang="en-US" sz="1000" dirty="0">
+                <a:solidFill>
+                  <a:srgbClr val="6FD39A"/>
                 </a:solidFill>
                 <a:latin typeface="Courier New" pitchFamily="34" charset="0"/>
                 <a:ea typeface="Courier New" pitchFamily="34" charset="-122"/>
                 <a:cs typeface="Courier New" pitchFamily="34" charset="-120"/>
               </a:rPr>
-              <a:t>app.get("/", async (req, res) =&gt; {</a:t>
-            </a:r>
-            <a:endParaRPr lang="en-US" sz="1200" dirty="0"/>
-          </a:p>
-          <a:p>
-            <a:pPr indent="0" marL="0">
-              <a:buNone/>
-            </a:pPr>
-            <a:r>
-              <a:rPr lang="en-US" sz="1200" dirty="0">
-                <a:solidFill>
-                  <a:srgbClr val="6FD39A"/>
+              <a:t>const pool = new Pool({ host: process.env.DB_HOST, … });</a:t>
+            </a:r>
+            <a:endParaRPr lang="en-US" sz="1000" dirty="0"/>
+          </a:p>
+          <a:p>
+            <a:pPr indent="0" marL="0">
+              <a:buNone/>
+            </a:pPr>
+            <a:r>
+              <a:rPr lang="en-US" sz="1000" dirty="0">
+                <a:solidFill>
+                  <a:srgbClr val="F29A85"/>
                 </a:solidFill>
                 <a:latin typeface="Courier New" pitchFamily="34" charset="0"/>
                 <a:ea typeface="Courier New" pitchFamily="34" charset="-122"/>
                 <a:cs typeface="Courier New" pitchFamily="34" charset="-120"/>
               </a:rPr>
-              <a:t>  const r = await pool.query(</a:t>
-            </a:r>
-            <a:endParaRPr lang="en-US" sz="1200" dirty="0"/>
-          </a:p>
-          <a:p>
-            <a:pPr indent="0" marL="0">
-              <a:buNone/>
-            </a:pPr>
-            <a:r>
-              <a:rPr lang="en-US" sz="1200" dirty="0">
+              <a:t>app.get("/", async (requisicao, resposta) =&gt; {</a:t>
+            </a:r>
+            <a:endParaRPr lang="en-US" sz="1000" dirty="0"/>
+          </a:p>
+          <a:p>
+            <a:pPr indent="0" marL="0">
+              <a:buNone/>
+            </a:pPr>
+            <a:r>
+              <a:rPr lang="en-US" sz="1000" dirty="0">
                 <a:solidFill>
                   <a:srgbClr val="6FD39A"/>
                 </a:solidFill>
@@ -7639,16 +7784,16 @@
                 <a:ea typeface="Courier New" pitchFamily="34" charset="-122"/>
                 <a:cs typeface="Courier New" pitchFamily="34" charset="-120"/>
               </a:rPr>
-              <a:t>    "SELECT * FROM notas ORDER BY " +</a:t>
-            </a:r>
-            <a:endParaRPr lang="en-US" sz="1200" dirty="0"/>
-          </a:p>
-          <a:p>
-            <a:pPr indent="0" marL="0">
-              <a:buNone/>
-            </a:pPr>
-            <a:r>
-              <a:rPr lang="en-US" sz="1200" dirty="0">
+              <a:t>  const resultado = await pool.query(</a:t>
+            </a:r>
+            <a:endParaRPr lang="en-US" sz="1000" dirty="0"/>
+          </a:p>
+          <a:p>
+            <a:pPr indent="0" marL="0">
+              <a:buNone/>
+            </a:pPr>
+            <a:r>
+              <a:rPr lang="en-US" sz="1000" dirty="0">
                 <a:solidFill>
                   <a:srgbClr val="6FD39A"/>
                 </a:solidFill>
@@ -7656,33 +7801,33 @@
                 <a:ea typeface="Courier New" pitchFamily="34" charset="-122"/>
                 <a:cs typeface="Courier New" pitchFamily="34" charset="-120"/>
               </a:rPr>
-              <a:t>    "favorita DESC, criado_em DESC");</a:t>
-            </a:r>
-            <a:endParaRPr lang="en-US" sz="1200" dirty="0"/>
-          </a:p>
-          <a:p>
-            <a:pPr indent="0" marL="0">
-              <a:buNone/>
-            </a:pPr>
-            <a:r>
-              <a:rPr lang="en-US" sz="1200" dirty="0">
-                <a:solidFill>
-                  <a:srgbClr val="F2B84B"/>
+              <a:t>    "SELECT * FROM notas ORDER BY " +</a:t>
+            </a:r>
+            <a:endParaRPr lang="en-US" sz="1000" dirty="0"/>
+          </a:p>
+          <a:p>
+            <a:pPr indent="0" marL="0">
+              <a:buNone/>
+            </a:pPr>
+            <a:r>
+              <a:rPr lang="en-US" sz="1000" dirty="0">
+                <a:solidFill>
+                  <a:srgbClr val="6FD39A"/>
                 </a:solidFill>
                 <a:latin typeface="Courier New" pitchFamily="34" charset="0"/>
                 <a:ea typeface="Courier New" pitchFamily="34" charset="-122"/>
                 <a:cs typeface="Courier New" pitchFamily="34" charset="-120"/>
               </a:rPr>
-              <a:t>  const html = r.rows.map((n) =&gt;</a:t>
-            </a:r>
-            <a:endParaRPr lang="en-US" sz="1200" dirty="0"/>
-          </a:p>
-          <a:p>
-            <a:pPr indent="0" marL="0">
-              <a:buNone/>
-            </a:pPr>
-            <a:r>
-              <a:rPr lang="en-US" sz="1200" dirty="0">
+              <a:t>    "favorita DESC, criado_em DESC");</a:t>
+            </a:r>
+            <a:endParaRPr lang="en-US" sz="1000" dirty="0"/>
+          </a:p>
+          <a:p>
+            <a:pPr indent="0" marL="0">
+              <a:buNone/>
+            </a:pPr>
+            <a:r>
+              <a:rPr lang="en-US" sz="1000" dirty="0">
                 <a:solidFill>
                   <a:srgbClr val="F2B84B"/>
                 </a:solidFill>
@@ -7690,16 +7835,16 @@
                 <a:ea typeface="Courier New" pitchFamily="34" charset="-122"/>
                 <a:cs typeface="Courier New" pitchFamily="34" charset="-120"/>
               </a:rPr>
-              <a:t>    `&lt;li&gt;${n.titulo}&lt;/li&gt;`).join("");</a:t>
-            </a:r>
-            <a:endParaRPr lang="en-US" sz="1200" dirty="0"/>
-          </a:p>
-          <a:p>
-            <a:pPr indent="0" marL="0">
-              <a:buNone/>
-            </a:pPr>
-            <a:r>
-              <a:rPr lang="en-US" sz="1200" dirty="0">
+              <a:t>  const linhas = resultado.rows.map((nota) =&gt; `</a:t>
+            </a:r>
+            <a:endParaRPr lang="en-US" sz="1000" dirty="0"/>
+          </a:p>
+          <a:p>
+            <a:pPr indent="0" marL="0">
+              <a:buNone/>
+            </a:pPr>
+            <a:r>
+              <a:rPr lang="en-US" sz="1000" dirty="0">
                 <a:solidFill>
                   <a:srgbClr val="F2B84B"/>
                 </a:solidFill>
@@ -7707,93 +7852,247 @@
                 <a:ea typeface="Courier New" pitchFamily="34" charset="-122"/>
                 <a:cs typeface="Courier New" pitchFamily="34" charset="-120"/>
               </a:rPr>
-              <a:t>  res.send(`&lt;ul&gt;${html}&lt;/ul&gt;`);</a:t>
-            </a:r>
-            <a:endParaRPr lang="en-US" sz="1200" dirty="0"/>
-          </a:p>
-          <a:p>
-            <a:pPr indent="0" marL="0">
-              <a:buNone/>
-            </a:pPr>
-            <a:r>
-              <a:rPr lang="en-US" sz="1200" dirty="0">
-                <a:solidFill>
-                  <a:srgbClr val="E8E8E8"/>
+              <a:t>    &lt;li&gt;&lt;form action="/notas/${nota.id}/favorita"&gt;</a:t>
+            </a:r>
+            <a:endParaRPr lang="en-US" sz="1000" dirty="0"/>
+          </a:p>
+          <a:p>
+            <a:pPr indent="0" marL="0">
+              <a:buNone/>
+            </a:pPr>
+            <a:r>
+              <a:rPr lang="en-US" sz="1000" dirty="0">
+                <a:solidFill>
+                  <a:srgbClr val="F2B84B"/>
                 </a:solidFill>
                 <a:latin typeface="Courier New" pitchFamily="34" charset="0"/>
                 <a:ea typeface="Courier New" pitchFamily="34" charset="-122"/>
                 <a:cs typeface="Courier New" pitchFamily="34" charset="-120"/>
               </a:rPr>
+              <a:t>      &lt;strong&gt;${escapar(nota.titulo)}&lt;/strong&gt;</a:t>
+            </a:r>
+            <a:endParaRPr lang="en-US" sz="1000" dirty="0"/>
+          </a:p>
+          <a:p>
+            <a:pPr indent="0" marL="0">
+              <a:buNone/>
+            </a:pPr>
+            <a:r>
+              <a:rPr lang="en-US" sz="1000" dirty="0">
+                <a:solidFill>
+                  <a:srgbClr val="F2B84B"/>
+                </a:solidFill>
+                <a:latin typeface="Courier New" pitchFamily="34" charset="0"/>
+                <a:ea typeface="Courier New" pitchFamily="34" charset="-122"/>
+                <a:cs typeface="Courier New" pitchFamily="34" charset="-120"/>
+              </a:rPr>
+              <a:t>      &lt;form action="/notas/${nota.id}/excluir"&gt;</a:t>
+            </a:r>
+            <a:endParaRPr lang="en-US" sz="1000" dirty="0"/>
+          </a:p>
+          <a:p>
+            <a:pPr indent="0" marL="0">
+              <a:buNone/>
+            </a:pPr>
+            <a:r>
+              <a:rPr lang="en-US" sz="1000" dirty="0">
+                <a:solidFill>
+                  <a:srgbClr val="F2B84B"/>
+                </a:solidFill>
+                <a:latin typeface="Courier New" pitchFamily="34" charset="0"/>
+                <a:ea typeface="Courier New" pitchFamily="34" charset="-122"/>
+                <a:cs typeface="Courier New" pitchFamily="34" charset="-120"/>
+              </a:rPr>
+              <a:t>    &lt;/li&gt;`).join("");</a:t>
+            </a:r>
+            <a:endParaRPr lang="en-US" sz="1000" dirty="0"/>
+          </a:p>
+          <a:p>
+            <a:pPr indent="0" marL="0">
+              <a:buNone/>
+            </a:pPr>
+            <a:r>
+              <a:rPr lang="en-US" sz="1000" dirty="0">
+                <a:solidFill>
+                  <a:srgbClr val="F2B84B"/>
+                </a:solidFill>
+                <a:latin typeface="Courier New" pitchFamily="34" charset="0"/>
+                <a:ea typeface="Courier New" pitchFamily="34" charset="-122"/>
+                <a:cs typeface="Courier New" pitchFamily="34" charset="-120"/>
+              </a:rPr>
+              <a:t>  resposta.send(`&lt;html&gt;&lt;style&gt;body { … }&lt;/style&gt;</a:t>
+            </a:r>
+            <a:endParaRPr lang="en-US" sz="1000" dirty="0"/>
+          </a:p>
+          <a:p>
+            <a:pPr indent="0" marL="0">
+              <a:buNone/>
+            </a:pPr>
+            <a:r>
+              <a:rPr lang="en-US" sz="1000" dirty="0">
+                <a:solidFill>
+                  <a:srgbClr val="F2B84B"/>
+                </a:solidFill>
+                <a:latin typeface="Courier New" pitchFamily="34" charset="0"/>
+                <a:ea typeface="Courier New" pitchFamily="34" charset="-122"/>
+                <a:cs typeface="Courier New" pitchFamily="34" charset="-120"/>
+              </a:rPr>
+              <a:t>    &lt;form method="POST" action="/notas"&gt;…&lt;/form&gt;</a:t>
+            </a:r>
+            <a:endParaRPr lang="en-US" sz="1000" dirty="0"/>
+          </a:p>
+          <a:p>
+            <a:pPr indent="0" marL="0">
+              <a:buNone/>
+            </a:pPr>
+            <a:r>
+              <a:rPr lang="en-US" sz="1000" dirty="0">
+                <a:solidFill>
+                  <a:srgbClr val="F2B84B"/>
+                </a:solidFill>
+                <a:latin typeface="Courier New" pitchFamily="34" charset="0"/>
+                <a:ea typeface="Courier New" pitchFamily="34" charset="-122"/>
+                <a:cs typeface="Courier New" pitchFamily="34" charset="-120"/>
+              </a:rPr>
+              <a:t>    &lt;ul&gt;${linhas}&lt;/ul&gt;&lt;/html&gt;`);</a:t>
+            </a:r>
+            <a:endParaRPr lang="en-US" sz="1000" dirty="0"/>
+          </a:p>
+          <a:p>
+            <a:pPr indent="0" marL="0">
+              <a:buNone/>
+            </a:pPr>
+            <a:r>
+              <a:rPr lang="en-US" sz="1000" dirty="0">
+                <a:solidFill>
+                  <a:srgbClr val="F29A85"/>
+                </a:solidFill>
+                <a:latin typeface="Courier New" pitchFamily="34" charset="0"/>
+                <a:ea typeface="Courier New" pitchFamily="34" charset="-122"/>
+                <a:cs typeface="Courier New" pitchFamily="34" charset="-120"/>
+              </a:rPr>
               <a:t>});</a:t>
             </a:r>
-            <a:endParaRPr lang="en-US" sz="1200" dirty="0"/>
-          </a:p>
-        </p:txBody>
-      </p:sp>
-      <p:sp>
-        <p:nvSpPr>
-          <p:cNvPr id="8" name="Text 6"/>
-          <p:cNvSpPr txBox="1"/>
-          <p:nvPr/>
-        </p:nvSpPr>
-        <p:spPr>
-          <a:xfrm>
-            <a:off x="4937760" y="4023360"/>
-            <a:ext cx="3566160" cy="365760"/>
-          </a:xfrm>
-          <a:prstGeom prst="rect">
-            <a:avLst/>
-          </a:prstGeom>
-          <a:noFill/>
-          <a:ln/>
-        </p:spPr>
-        <p:txBody>
-          <a:bodyPr wrap="square" lIns="0" tIns="0" rIns="0" bIns="0" rtlCol="0" anchor="ctr"/>
-          <a:lstStyle/>
-          <a:p>
-            <a:pPr indent="0" marL="0">
-              <a:buNone/>
-            </a:pPr>
-            <a:r>
-              <a:rPr lang="en-US" sz="1300" b="1" dirty="0">
+            <a:endParaRPr lang="en-US" sz="1000" dirty="0"/>
+          </a:p>
+          <a:p>
+            <a:pPr indent="0" marL="0">
+              <a:buNone/>
+            </a:pPr>
+            <a:r>
+              <a:rPr lang="en-US" sz="1000" dirty="0">
                 <a:solidFill>
                   <a:srgbClr val="F29A85"/>
                 </a:solidFill>
-                <a:latin typeface="Arial" pitchFamily="34" charset="0"/>
-                <a:ea typeface="Arial" pitchFamily="34" charset="-122"/>
-                <a:cs typeface="Arial" pitchFamily="34" charset="-120"/>
-              </a:rPr>
-              <a:t>■ Controller  </a:t>
-            </a:r>
-            <a:pPr indent="0" marL="0">
-              <a:buNone/>
-            </a:pPr>
-            <a:r>
-              <a:rPr lang="en-US" sz="1300" b="1" dirty="0">
+                <a:latin typeface="Courier New" pitchFamily="34" charset="0"/>
+                <a:ea typeface="Courier New" pitchFamily="34" charset="-122"/>
+                <a:cs typeface="Courier New" pitchFamily="34" charset="-120"/>
+              </a:rPr>
+              <a:t>app.post("/notas", async (requisicao, resposta) =&gt; {</a:t>
+            </a:r>
+            <a:endParaRPr lang="en-US" sz="1000" dirty="0"/>
+          </a:p>
+          <a:p>
+            <a:pPr indent="0" marL="0">
+              <a:buNone/>
+            </a:pPr>
+            <a:r>
+              <a:rPr lang="en-US" sz="1000" dirty="0">
+                <a:solidFill>
+                  <a:srgbClr val="F29A85"/>
+                </a:solidFill>
+                <a:latin typeface="Courier New" pitchFamily="34" charset="0"/>
+                <a:ea typeface="Courier New" pitchFamily="34" charset="-122"/>
+                <a:cs typeface="Courier New" pitchFamily="34" charset="-120"/>
+              </a:rPr>
+              <a:t>  const { titulo, conteudo } = requisicao.body;</a:t>
+            </a:r>
+            <a:endParaRPr lang="en-US" sz="1000" dirty="0"/>
+          </a:p>
+          <a:p>
+            <a:pPr indent="0" marL="0">
+              <a:buNone/>
+            </a:pPr>
+            <a:r>
+              <a:rPr lang="en-US" sz="1000" dirty="0">
                 <a:solidFill>
                   <a:srgbClr val="6FD39A"/>
                 </a:solidFill>
-                <a:latin typeface="Arial" pitchFamily="34" charset="0"/>
-                <a:ea typeface="Arial" pitchFamily="34" charset="-122"/>
-                <a:cs typeface="Arial" pitchFamily="34" charset="-120"/>
-              </a:rPr>
-              <a:t>■ Model  </a:t>
-            </a:r>
-            <a:pPr indent="0" marL="0">
-              <a:buNone/>
-            </a:pPr>
-            <a:r>
-              <a:rPr lang="en-US" sz="1300" b="1" dirty="0">
-                <a:solidFill>
-                  <a:srgbClr val="F2B84B"/>
-                </a:solidFill>
-                <a:latin typeface="Arial" pitchFamily="34" charset="0"/>
-                <a:ea typeface="Arial" pitchFamily="34" charset="-122"/>
-                <a:cs typeface="Arial" pitchFamily="34" charset="-120"/>
-              </a:rPr>
-              <a:t>■ View</a:t>
-            </a:r>
-            <a:endParaRPr lang="en-US" sz="1300" dirty="0"/>
+                <a:latin typeface="Courier New" pitchFamily="34" charset="0"/>
+                <a:ea typeface="Courier New" pitchFamily="34" charset="-122"/>
+                <a:cs typeface="Courier New" pitchFamily="34" charset="-120"/>
+              </a:rPr>
+              <a:t>  if (!titulo) return resposta.redirect("/?erro=…");</a:t>
+            </a:r>
+            <a:endParaRPr lang="en-US" sz="1000" dirty="0"/>
+          </a:p>
+          <a:p>
+            <a:pPr indent="0" marL="0">
+              <a:buNone/>
+            </a:pPr>
+            <a:r>
+              <a:rPr lang="en-US" sz="1000" dirty="0">
+                <a:solidFill>
+                  <a:srgbClr val="6FD39A"/>
+                </a:solidFill>
+                <a:latin typeface="Courier New" pitchFamily="34" charset="0"/>
+                <a:ea typeface="Courier New" pitchFamily="34" charset="-122"/>
+                <a:cs typeface="Courier New" pitchFamily="34" charset="-120"/>
+              </a:rPr>
+              <a:t>  await pool.query("INSERT INTO notas …", [titulo]);</a:t>
+            </a:r>
+            <a:endParaRPr lang="en-US" sz="1000" dirty="0"/>
+          </a:p>
+          <a:p>
+            <a:pPr indent="0" marL="0">
+              <a:buNone/>
+            </a:pPr>
+            <a:r>
+              <a:rPr lang="en-US" sz="1000" dirty="0">
+                <a:solidFill>
+                  <a:srgbClr val="F29A85"/>
+                </a:solidFill>
+                <a:latin typeface="Courier New" pitchFamily="34" charset="0"/>
+                <a:ea typeface="Courier New" pitchFamily="34" charset="-122"/>
+                <a:cs typeface="Courier New" pitchFamily="34" charset="-120"/>
+              </a:rPr>
+              <a:t>  resposta.redirect("/");</a:t>
+            </a:r>
+            <a:endParaRPr lang="en-US" sz="1000" dirty="0"/>
+          </a:p>
+          <a:p>
+            <a:pPr indent="0" marL="0">
+              <a:buNone/>
+            </a:pPr>
+            <a:r>
+              <a:rPr lang="en-US" sz="1000" dirty="0">
+                <a:solidFill>
+                  <a:srgbClr val="F29A85"/>
+                </a:solidFill>
+                <a:latin typeface="Courier New" pitchFamily="34" charset="0"/>
+                <a:ea typeface="Courier New" pitchFamily="34" charset="-122"/>
+                <a:cs typeface="Courier New" pitchFamily="34" charset="-120"/>
+              </a:rPr>
+              <a:t>});</a:t>
+            </a:r>
+            <a:endParaRPr lang="en-US" sz="1000" dirty="0"/>
+          </a:p>
+          <a:p>
+            <a:pPr indent="0" marL="0">
+              <a:buNone/>
+            </a:pPr>
+            <a:r>
+              <a:rPr lang="en-US" sz="1000" dirty="0">
+                <a:solidFill>
+                  <a:srgbClr val="8B93A5"/>
+                </a:solidFill>
+                <a:latin typeface="Courier New" pitchFamily="34" charset="0"/>
+                <a:ea typeface="Courier New" pitchFamily="34" charset="-122"/>
+                <a:cs typeface="Courier New" pitchFamily="34" charset="-120"/>
+              </a:rPr>
+              <a:t>// … + rotas de excluir e favoritar, tudo igual</a:t>
+            </a:r>
+            <a:endParaRPr lang="en-US" sz="1000" dirty="0"/>
           </a:p>
         </p:txBody>
       </p:sp>

</xml_diff>

<commit_message>
Swap verification question and add interview prep doc
Replace the slide 17 question with one about the existing "favorites
first" rule in the model, so it can be shown without new code. Add
perguntas-banca.md with likely panel questions, including the Gang of
Four and its link to MVC, and regenerate the slide and plan PDFs.

Co-Authored-By: Claude Opus 5.5 <noreply@anthropic.com>
</commit_message>
<xml_diff>
--- a/docs/aula-mvc.pptx
+++ b/docs/aula-mvc.pptx
@@ -1225,7 +1225,7 @@
           <a:p>
             <a:r>
               <a:rPr lang="en-US" dirty="0"/>
-              <a:t>Funcionou! E respondendo: a regra de negócio entraria no Model. A mudança fica isolada — esse é o ganho do MVC.</a:t>
+              <a:t>Funcionou! Agora, uma pergunta para vocês: a regra 'as favoritas aparecem primeiro' — ela está na View ou no Model? Parece coisa da tela, porque é a tela que mostra a ordem. Mas é regra de negócio, então está no Model: é o ORDER BY favorita DESC no Nota.js. (Abrir o Nota.js e mostrar a linha com o comentário 'Regra de negócio'.) A View só exibe na ordem que recebe. Se amanhã a regra mudar, mexemos só no Model — esse é o ganho do MVC.</a:t>
             </a:r>
             <a:endParaRPr lang="en-US" dirty="0"/>
           </a:p>
@@ -7064,7 +7064,7 @@
                 <a:ea typeface="Arial" pitchFamily="34" charset="-122"/>
                 <a:cs typeface="Arial" pitchFamily="34" charset="-120"/>
               </a:rPr>
-              <a:t>e se a regra fosse "só excluir notas com mais de 1 dia"? Em qual camada?</a:t>
+              <a:t>a regra "as favoritas aparecem primeiro" está na View ou no Model?</a:t>
             </a:r>
             <a:endParaRPr lang="en-US" sz="1700" dirty="0"/>
           </a:p>

</xml_diff>